<commit_message>
[TTF-B] V4: feedback general
</commit_message>
<xml_diff>
--- a/Otros docs/Diagrama componentes.pptx
+++ b/Otros docs/Diagrama componentes.pptx
@@ -206,7 +206,7 @@
           <a:p>
             <a:fld id="{BC99F65C-4503-46EF-A20F-62732069D2F2}" type="datetimeFigureOut">
               <a:rPr lang="en-US" smtClean="0"/>
-              <a:t>4/3/2026</a:t>
+              <a:t>5/16/2026</a:t>
             </a:fld>
             <a:endParaRPr lang="en-US"/>
           </a:p>
@@ -711,7 +711,7 @@
           <a:p>
             <a:fld id="{27DDF7D6-43EF-4CD7-AB27-C0C40C6A6332}" type="datetimeFigureOut">
               <a:rPr lang="en-US" smtClean="0"/>
-              <a:t>4/3/2026</a:t>
+              <a:t>5/16/2026</a:t>
             </a:fld>
             <a:endParaRPr lang="en-US"/>
           </a:p>
@@ -909,7 +909,7 @@
           <a:p>
             <a:fld id="{27DDF7D6-43EF-4CD7-AB27-C0C40C6A6332}" type="datetimeFigureOut">
               <a:rPr lang="en-US" smtClean="0"/>
-              <a:t>4/3/2026</a:t>
+              <a:t>5/16/2026</a:t>
             </a:fld>
             <a:endParaRPr lang="en-US"/>
           </a:p>
@@ -1117,7 +1117,7 @@
           <a:p>
             <a:fld id="{27DDF7D6-43EF-4CD7-AB27-C0C40C6A6332}" type="datetimeFigureOut">
               <a:rPr lang="en-US" smtClean="0"/>
-              <a:t>4/3/2026</a:t>
+              <a:t>5/16/2026</a:t>
             </a:fld>
             <a:endParaRPr lang="en-US"/>
           </a:p>
@@ -1315,7 +1315,7 @@
           <a:p>
             <a:fld id="{27DDF7D6-43EF-4CD7-AB27-C0C40C6A6332}" type="datetimeFigureOut">
               <a:rPr lang="en-US" smtClean="0"/>
-              <a:t>4/3/2026</a:t>
+              <a:t>5/16/2026</a:t>
             </a:fld>
             <a:endParaRPr lang="en-US"/>
           </a:p>
@@ -1590,7 +1590,7 @@
           <a:p>
             <a:fld id="{27DDF7D6-43EF-4CD7-AB27-C0C40C6A6332}" type="datetimeFigureOut">
               <a:rPr lang="en-US" smtClean="0"/>
-              <a:t>4/3/2026</a:t>
+              <a:t>5/16/2026</a:t>
             </a:fld>
             <a:endParaRPr lang="en-US"/>
           </a:p>
@@ -1855,7 +1855,7 @@
           <a:p>
             <a:fld id="{27DDF7D6-43EF-4CD7-AB27-C0C40C6A6332}" type="datetimeFigureOut">
               <a:rPr lang="en-US" smtClean="0"/>
-              <a:t>4/3/2026</a:t>
+              <a:t>5/16/2026</a:t>
             </a:fld>
             <a:endParaRPr lang="en-US"/>
           </a:p>
@@ -2267,7 +2267,7 @@
           <a:p>
             <a:fld id="{27DDF7D6-43EF-4CD7-AB27-C0C40C6A6332}" type="datetimeFigureOut">
               <a:rPr lang="en-US" smtClean="0"/>
-              <a:t>4/3/2026</a:t>
+              <a:t>5/16/2026</a:t>
             </a:fld>
             <a:endParaRPr lang="en-US"/>
           </a:p>
@@ -2408,7 +2408,7 @@
           <a:p>
             <a:fld id="{27DDF7D6-43EF-4CD7-AB27-C0C40C6A6332}" type="datetimeFigureOut">
               <a:rPr lang="en-US" smtClean="0"/>
-              <a:t>4/3/2026</a:t>
+              <a:t>5/16/2026</a:t>
             </a:fld>
             <a:endParaRPr lang="en-US"/>
           </a:p>
@@ -2521,7 +2521,7 @@
           <a:p>
             <a:fld id="{27DDF7D6-43EF-4CD7-AB27-C0C40C6A6332}" type="datetimeFigureOut">
               <a:rPr lang="en-US" smtClean="0"/>
-              <a:t>4/3/2026</a:t>
+              <a:t>5/16/2026</a:t>
             </a:fld>
             <a:endParaRPr lang="en-US"/>
           </a:p>
@@ -2832,7 +2832,7 @@
           <a:p>
             <a:fld id="{27DDF7D6-43EF-4CD7-AB27-C0C40C6A6332}" type="datetimeFigureOut">
               <a:rPr lang="en-US" smtClean="0"/>
-              <a:t>4/3/2026</a:t>
+              <a:t>5/16/2026</a:t>
             </a:fld>
             <a:endParaRPr lang="en-US"/>
           </a:p>
@@ -3120,7 +3120,7 @@
           <a:p>
             <a:fld id="{27DDF7D6-43EF-4CD7-AB27-C0C40C6A6332}" type="datetimeFigureOut">
               <a:rPr lang="en-US" smtClean="0"/>
-              <a:t>4/3/2026</a:t>
+              <a:t>5/16/2026</a:t>
             </a:fld>
             <a:endParaRPr lang="en-US"/>
           </a:p>
@@ -3361,7 +3361,7 @@
           <a:p>
             <a:fld id="{27DDF7D6-43EF-4CD7-AB27-C0C40C6A6332}" type="datetimeFigureOut">
               <a:rPr lang="en-US" smtClean="0"/>
-              <a:t>4/3/2026</a:t>
+              <a:t>5/16/2026</a:t>
             </a:fld>
             <a:endParaRPr lang="en-US"/>
           </a:p>
@@ -6701,7 +6701,15 @@
               <a:pPr algn="ctr"/>
               <a:r>
                 <a:rPr lang="en-US" sz="1400" b="1" dirty="0"/>
-                <a:t>Módulo de Generación de modelos</a:t>
+                <a:t>Módulo de </a:t>
+              </a:r>
+              <a:r>
+                <a:rPr lang="en-US" sz="1400" b="1" dirty="0" err="1"/>
+                <a:t>generación</a:t>
+              </a:r>
+              <a:r>
+                <a:rPr lang="en-US" sz="1400" b="1" dirty="0"/>
+                <a:t> de modelos</a:t>
               </a:r>
             </a:p>
           </p:txBody>
@@ -8213,7 +8221,7 @@
                     <a:schemeClr val="tx1"/>
                   </a:solidFill>
                 </a:rPr>
-                <a:t>Selección de Features</a:t>
+                <a:t>Selección de features</a:t>
               </a:r>
             </a:p>
           </p:txBody>
@@ -8476,7 +8484,7 @@
                     <a:schemeClr val="tx1"/>
                   </a:solidFill>
                 </a:rPr>
-                <a:t>Optimización de Hiperparámetros</a:t>
+                <a:t>Optimización de hiperparámetros</a:t>
               </a:r>
             </a:p>
           </p:txBody>
@@ -8805,7 +8813,7 @@
               <a:pPr algn="ctr"/>
               <a:r>
                 <a:rPr lang="en-US" dirty="0"/>
-                <a:t>Evaluación y Refinamiento</a:t>
+                <a:t>Evaluación y refinamiento</a:t>
               </a:r>
             </a:p>
           </p:txBody>
@@ -13996,7 +14004,7 @@
                 <a:pPr algn="ctr"/>
                 <a:r>
                   <a:rPr lang="en-US" sz="1400" dirty="0"/>
-                  <a:t>Análisis Exploratorio</a:t>
+                  <a:t>Análisis exploratorio</a:t>
                 </a:r>
               </a:p>
             </p:txBody>
@@ -14033,7 +14041,7 @@
               <a:pPr algn="ctr"/>
               <a:r>
                 <a:rPr lang="en-US" sz="1400" b="1" dirty="0"/>
-                <a:t>Análisis Exploratorio</a:t>
+                <a:t>Análisis exploratorio</a:t>
               </a:r>
             </a:p>
           </p:txBody>

</xml_diff>